<commit_message>
revised the flowchart again
</commit_message>
<xml_diff>
--- a/plotting/流程图/final.pptx
+++ b/plotting/流程图/final.pptx
@@ -8,7 +8,7 @@
     <p:notesMasterId r:id="rId3"/>
   </p:notesMasterIdLst>
   <p:sldIdLst>
-    <p:sldId id="259" r:id="rId2"/>
+    <p:sldId id="265" r:id="rId2"/>
   </p:sldIdLst>
   <p:sldSz cx="17145000" cy="10477500"/>
   <p:notesSz cx="6858000" cy="9144000"/>
@@ -763,7 +763,7 @@
               </a:defRPr>
             </a:pPr>
             <a:r>
-              <a:rPr sz="2657" b="1">
+              <a:rPr sz="2657" b="1" dirty="0">
                 <a:solidFill>
                   <a:srgbClr val="246A96"/>
                 </a:solidFill>
@@ -771,7 +771,7 @@
                 <a:ea typeface="Times New Roman"/>
                 <a:cs typeface="Times New Roman"/>
               </a:rPr>
-              <a:t>A   From symbols to RF</a:t>
+              <a:t>From symbols to RF</a:t>
             </a:r>
           </a:p>
         </p:txBody>
@@ -792,7 +792,7 @@
         </p:nvSpPr>
         <p:spPr>
           <a:xfrm>
-            <a:off x="8039746" y="213102"/>
+            <a:off x="8483708" y="213102"/>
             <a:ext cx="3773676" cy="443962"/>
           </a:xfrm>
           <a:prstGeom prst="rect">
@@ -810,7 +810,7 @@
           </a:bodyPr>
           <a:lstStyle/>
           <a:p>
-            <a:pPr algn="l">
+            <a:pPr>
               <a:defRPr sz="2625" b="1">
                 <a:solidFill>
                   <a:srgbClr val="246A96"/>
@@ -821,7 +821,7 @@
               </a:defRPr>
             </a:pPr>
             <a:r>
-              <a:rPr sz="2447" b="1">
+              <a:rPr sz="2447" b="1" dirty="0">
                 <a:solidFill>
                   <a:srgbClr val="246A96"/>
                 </a:solidFill>
@@ -829,57 +829,10 @@
                 <a:ea typeface="Times New Roman"/>
                 <a:cs typeface="Times New Roman"/>
               </a:rPr>
-              <a:t>B   Far-field propagation</a:t>
+              <a:t>Far-field propagation</a:t>
             </a:r>
-          </a:p>
-        </p:txBody>
-      </p:sp>
-      <p:sp>
-        <p:nvSpPr>
-          <p:cNvPr id="3" name="visual-3">
-            <a:extLst>
-              <a:ext uri="{FF2B5EF4-FFF2-40B4-BE49-F238E27FC236}">
-                <a16:creationId xmlns:a16="http://schemas.microsoft.com/office/drawing/2014/main" id="{38117F04-9B3F-4228-979E-5F1552F95CDA}"/>
-              </a:ext>
-            </a:extLst>
-          </p:cNvPr>
-          <p:cNvSpPr>
-            <a:spLocks noGrp="1"/>
-          </p:cNvSpPr>
-          <p:nvPr/>
-        </p:nvSpPr>
-        <p:spPr>
-          <a:xfrm>
-            <a:off x="11884456" y="213102"/>
-            <a:ext cx="4288672" cy="443962"/>
-          </a:xfrm>
-          <a:prstGeom prst="rect">
-            <a:avLst/>
-          </a:prstGeom>
-          <a:noFill/>
-          <a:ln w="0">
-            <a:noFill/>
-            <a:prstDash val="solid"/>
-          </a:ln>
-        </p:spPr>
-        <p:txBody>
-          <a:bodyPr wrap="none" lIns="0" tIns="0" rIns="0" bIns="0" anchor="ctr">
-            <a:noAutofit/>
-          </a:bodyPr>
-          <a:lstStyle/>
-          <a:p>
-            <a:pPr algn="l">
-              <a:defRPr sz="2625" b="1">
-                <a:solidFill>
-                  <a:srgbClr val="246A96"/>
-                </a:solidFill>
-                <a:latin typeface="Times New Roman"/>
-                <a:ea typeface="Times New Roman"/>
-                <a:cs typeface="Times New Roman"/>
-              </a:defRPr>
-            </a:pPr>
             <a:r>
-              <a:rPr sz="2447" b="1">
+              <a:rPr lang="en-US" altLang="zh-CN" sz="2447" b="1" dirty="0">
                 <a:solidFill>
                   <a:srgbClr val="246A96"/>
                 </a:solidFill>
@@ -887,7 +840,7 @@
                 <a:ea typeface="Times New Roman"/>
                 <a:cs typeface="Times New Roman"/>
               </a:rPr>
-              <a:t>C   Holographic reception</a:t>
+              <a:t> and  Holographic reception</a:t>
             </a:r>
           </a:p>
         </p:txBody>
@@ -9113,64 +9066,6 @@
       </p:sp>
       <p:sp>
         <p:nvSpPr>
-          <p:cNvPr id="59" name="visual-59">
-            <a:extLst>
-              <a:ext uri="{FF2B5EF4-FFF2-40B4-BE49-F238E27FC236}">
-                <a16:creationId xmlns:a16="http://schemas.microsoft.com/office/drawing/2014/main" id="{208FD410-88C5-465A-8362-3525A3A5209D}"/>
-              </a:ext>
-            </a:extLst>
-          </p:cNvPr>
-          <p:cNvSpPr>
-            <a:spLocks noGrp="1"/>
-          </p:cNvSpPr>
-          <p:nvPr/>
-        </p:nvSpPr>
-        <p:spPr>
-          <a:xfrm>
-            <a:off x="8235089" y="2992304"/>
-            <a:ext cx="1544987" cy="275256"/>
-          </a:xfrm>
-          <a:prstGeom prst="rect">
-            <a:avLst/>
-          </a:prstGeom>
-          <a:noFill/>
-          <a:ln w="0">
-            <a:noFill/>
-            <a:prstDash val="solid"/>
-          </a:ln>
-        </p:spPr>
-        <p:txBody>
-          <a:bodyPr wrap="none" lIns="0" tIns="0" rIns="0" bIns="0" anchor="ctr">
-            <a:noAutofit/>
-          </a:bodyPr>
-          <a:lstStyle/>
-          <a:p>
-            <a:pPr algn="l">
-              <a:defRPr sz="1950">
-                <a:solidFill>
-                  <a:srgbClr val="2C7A86"/>
-                </a:solidFill>
-                <a:latin typeface="Times New Roman"/>
-                <a:ea typeface="Times New Roman"/>
-                <a:cs typeface="Times New Roman"/>
-              </a:defRPr>
-            </a:pPr>
-            <a:r>
-              <a:rPr sz="1818">
-                <a:solidFill>
-                  <a:srgbClr val="2C7A86"/>
-                </a:solidFill>
-                <a:latin typeface="Times New Roman"/>
-                <a:ea typeface="Times New Roman"/>
-                <a:cs typeface="Times New Roman"/>
-              </a:rPr>
-              <a:t>Other users</a:t>
-            </a:r>
-          </a:p>
-        </p:txBody>
-      </p:sp>
-      <p:sp>
-        <p:nvSpPr>
           <p:cNvPr id="60" name="visual-60">
             <a:extLst>
               <a:ext uri="{FF2B5EF4-FFF2-40B4-BE49-F238E27FC236}">
@@ -9772,7 +9667,7 @@
               </a:defRPr>
             </a:pPr>
             <a:r>
-              <a:rPr sz="1958">
+              <a:rPr sz="1958" dirty="0">
                 <a:solidFill>
                   <a:srgbClr val="566574"/>
                 </a:solidFill>
@@ -12591,100 +12486,6 @@
             </a:r>
           </a:p>
         </p:txBody>
-      </p:sp>
-      <p:sp>
-        <p:nvSpPr>
-          <p:cNvPr id="129" name="path-128">
-            <a:extLst>
-              <a:ext uri="{FF2B5EF4-FFF2-40B4-BE49-F238E27FC236}">
-                <a16:creationId xmlns:a16="http://schemas.microsoft.com/office/drawing/2014/main" id="{1A7CDA50-5AC9-4B67-8340-BE9795A9B8CA}"/>
-              </a:ext>
-            </a:extLst>
-          </p:cNvPr>
-          <p:cNvSpPr>
-            <a:spLocks noGrp="1"/>
-          </p:cNvSpPr>
-          <p:nvPr/>
-        </p:nvSpPr>
-        <p:spPr>
-          <a:xfrm>
-            <a:off x="15578219" y="2184293"/>
-            <a:ext cx="385359" cy="888"/>
-          </a:xfrm>
-          <a:custGeom>
-            <a:avLst/>
-            <a:gdLst/>
-            <a:ahLst/>
-            <a:cxnLst/>
-            <a:rect l="0" t="0" r="0" b="0"/>
-            <a:pathLst>
-              <a:path w="413385" h="953">
-                <a:moveTo>
-                  <a:pt x="0" y="0"/>
-                </a:moveTo>
-                <a:lnTo>
-                  <a:pt x="413385" y="0"/>
-                </a:lnTo>
-              </a:path>
-            </a:pathLst>
-          </a:custGeom>
-          <a:noFill/>
-          <a:ln w="24765">
-            <a:solidFill>
-              <a:srgbClr val="246A96"/>
-            </a:solidFill>
-            <a:prstDash val="solid"/>
-          </a:ln>
-        </p:spPr>
-      </p:sp>
-      <p:sp>
-        <p:nvSpPr>
-          <p:cNvPr id="130" name="path-129">
-            <a:extLst>
-              <a:ext uri="{FF2B5EF4-FFF2-40B4-BE49-F238E27FC236}">
-                <a16:creationId xmlns:a16="http://schemas.microsoft.com/office/drawing/2014/main" id="{1D91A49A-6F62-4502-882D-F0470AC18778}"/>
-              </a:ext>
-            </a:extLst>
-          </p:cNvPr>
-          <p:cNvSpPr>
-            <a:spLocks noGrp="1"/>
-          </p:cNvSpPr>
-          <p:nvPr/>
-        </p:nvSpPr>
-        <p:spPr>
-          <a:xfrm>
-            <a:off x="15942267" y="2141672"/>
-            <a:ext cx="106551" cy="85241"/>
-          </a:xfrm>
-          <a:custGeom>
-            <a:avLst/>
-            <a:gdLst/>
-            <a:ahLst/>
-            <a:cxnLst/>
-            <a:rect l="0" t="0" r="0" b="0"/>
-            <a:pathLst>
-              <a:path w="114300" h="91440">
-                <a:moveTo>
-                  <a:pt x="114300" y="45720"/>
-                </a:moveTo>
-                <a:lnTo>
-                  <a:pt x="0" y="91440"/>
-                </a:lnTo>
-                <a:lnTo>
-                  <a:pt x="0" y="0"/>
-                </a:lnTo>
-                <a:close/>
-              </a:path>
-            </a:pathLst>
-          </a:custGeom>
-          <a:solidFill>
-            <a:srgbClr val="246A96"/>
-          </a:solidFill>
-          <a:ln w="0">
-            <a:noFill/>
-            <a:prstDash val="solid"/>
-          </a:ln>
-        </p:spPr>
       </p:sp>
       <p:sp>
         <p:nvSpPr>
@@ -13889,8 +13690,8 @@
         </p:nvSpPr>
         <p:spPr>
           <a:xfrm>
-            <a:off x="16048818" y="2184293"/>
-            <a:ext cx="168706" cy="888"/>
+            <a:off x="16048817" y="2184292"/>
+            <a:ext cx="382252" cy="53714"/>
           </a:xfrm>
           <a:custGeom>
             <a:avLst/>
@@ -13934,7 +13735,7 @@
         </p:nvSpPr>
         <p:spPr>
           <a:xfrm>
-            <a:off x="16217524" y="2184292"/>
+            <a:off x="16432845" y="2190761"/>
             <a:ext cx="888" cy="2610496"/>
           </a:xfrm>
           <a:custGeom>
@@ -13979,8 +13780,8 @@
         </p:nvSpPr>
         <p:spPr>
           <a:xfrm flipV="1">
-            <a:off x="8057505" y="4726419"/>
-            <a:ext cx="8160019" cy="67095"/>
+            <a:off x="8057505" y="4716690"/>
+            <a:ext cx="8373564" cy="87904"/>
           </a:xfrm>
           <a:custGeom>
             <a:avLst/>
@@ -14710,8 +14511,8 @@
         </p:nvSpPr>
         <p:spPr>
           <a:xfrm>
-            <a:off x="2516859" y="7644589"/>
-            <a:ext cx="9633974" cy="45719"/>
+            <a:off x="2502651" y="7667941"/>
+            <a:ext cx="9452839" cy="45719"/>
           </a:xfrm>
           <a:custGeom>
             <a:avLst/>
@@ -14741,6 +14542,51 @@
       </p:sp>
       <p:sp>
         <p:nvSpPr>
+          <p:cNvPr id="171" name="path-168">
+            <a:extLst>
+              <a:ext uri="{FF2B5EF4-FFF2-40B4-BE49-F238E27FC236}">
+                <a16:creationId xmlns:a16="http://schemas.microsoft.com/office/drawing/2014/main" id="{C6992C50-3C71-4AC3-83F4-2D86040D3176}"/>
+              </a:ext>
+            </a:extLst>
+          </p:cNvPr>
+          <p:cNvSpPr>
+            <a:spLocks noGrp="1"/>
+          </p:cNvSpPr>
+          <p:nvPr/>
+        </p:nvSpPr>
+        <p:spPr>
+          <a:xfrm>
+            <a:off x="11946610" y="7662782"/>
+            <a:ext cx="229084" cy="888"/>
+          </a:xfrm>
+          <a:custGeom>
+            <a:avLst/>
+            <a:gdLst/>
+            <a:ahLst/>
+            <a:cxnLst/>
+            <a:rect l="0" t="0" r="0" b="0"/>
+            <a:pathLst>
+              <a:path w="245745" h="953">
+                <a:moveTo>
+                  <a:pt x="0" y="0"/>
+                </a:moveTo>
+                <a:lnTo>
+                  <a:pt x="245745" y="0"/>
+                </a:lnTo>
+              </a:path>
+            </a:pathLst>
+          </a:custGeom>
+          <a:noFill/>
+          <a:ln w="14288">
+            <a:solidFill>
+              <a:srgbClr val="203344"/>
+            </a:solidFill>
+            <a:prstDash val="solid"/>
+          </a:ln>
+        </p:spPr>
+      </p:sp>
+      <p:sp>
+        <p:nvSpPr>
           <p:cNvPr id="172" name="path-169">
             <a:extLst>
               <a:ext uri="{FF2B5EF4-FFF2-40B4-BE49-F238E27FC236}">
@@ -14755,7 +14601,7 @@
         </p:nvSpPr>
         <p:spPr>
           <a:xfrm>
-            <a:off x="12144892" y="7618542"/>
+            <a:off x="12174867" y="7630816"/>
             <a:ext cx="79913" cy="63931"/>
           </a:xfrm>
           <a:custGeom>
@@ -27235,10 +27081,116 @@
           </a:ln>
         </p:spPr>
       </p:sp>
+      <p:sp>
+        <p:nvSpPr>
+          <p:cNvPr id="142" name="矩形 141">
+            <a:extLst>
+              <a:ext uri="{FF2B5EF4-FFF2-40B4-BE49-F238E27FC236}">
+                <a16:creationId xmlns:a16="http://schemas.microsoft.com/office/drawing/2014/main" id="{36517AA0-BB1B-426F-9752-D1D83465285A}"/>
+              </a:ext>
+            </a:extLst>
+          </p:cNvPr>
+          <p:cNvSpPr/>
+          <p:nvPr/>
+        </p:nvSpPr>
+        <p:spPr>
+          <a:xfrm>
+            <a:off x="875489" y="825768"/>
+            <a:ext cx="6807944" cy="3684499"/>
+          </a:xfrm>
+          <a:prstGeom prst="rect">
+            <a:avLst/>
+          </a:prstGeom>
+          <a:noFill/>
+          <a:ln>
+            <a:solidFill>
+              <a:srgbClr val="156082"/>
+            </a:solidFill>
+            <a:prstDash val="dash"/>
+          </a:ln>
+        </p:spPr>
+        <p:style>
+          <a:lnRef idx="2">
+            <a:schemeClr val="accent1">
+              <a:shade val="50000"/>
+            </a:schemeClr>
+          </a:lnRef>
+          <a:fillRef idx="1">
+            <a:schemeClr val="accent1"/>
+          </a:fillRef>
+          <a:effectRef idx="0">
+            <a:schemeClr val="accent1"/>
+          </a:effectRef>
+          <a:fontRef idx="minor">
+            <a:schemeClr val="lt1"/>
+          </a:fontRef>
+        </p:style>
+        <p:txBody>
+          <a:bodyPr rtlCol="0" anchor="ctr"/>
+          <a:lstStyle/>
+          <a:p>
+            <a:pPr algn="ctr"/>
+            <a:endParaRPr lang="zh-CN" altLang="en-US"/>
+          </a:p>
+        </p:txBody>
+      </p:sp>
+      <p:sp>
+        <p:nvSpPr>
+          <p:cNvPr id="419" name="矩形 418">
+            <a:extLst>
+              <a:ext uri="{FF2B5EF4-FFF2-40B4-BE49-F238E27FC236}">
+                <a16:creationId xmlns:a16="http://schemas.microsoft.com/office/drawing/2014/main" id="{7BB264D0-BC60-4242-8FA1-78F01AF57B01}"/>
+              </a:ext>
+            </a:extLst>
+          </p:cNvPr>
+          <p:cNvSpPr/>
+          <p:nvPr/>
+        </p:nvSpPr>
+        <p:spPr>
+          <a:xfrm>
+            <a:off x="8337847" y="825768"/>
+            <a:ext cx="7709194" cy="3684499"/>
+          </a:xfrm>
+          <a:prstGeom prst="rect">
+            <a:avLst/>
+          </a:prstGeom>
+          <a:noFill/>
+          <a:ln>
+            <a:solidFill>
+              <a:srgbClr val="156082"/>
+            </a:solidFill>
+            <a:prstDash val="dash"/>
+          </a:ln>
+        </p:spPr>
+        <p:style>
+          <a:lnRef idx="2">
+            <a:schemeClr val="accent1">
+              <a:shade val="50000"/>
+            </a:schemeClr>
+          </a:lnRef>
+          <a:fillRef idx="1">
+            <a:schemeClr val="accent1"/>
+          </a:fillRef>
+          <a:effectRef idx="0">
+            <a:schemeClr val="accent1"/>
+          </a:effectRef>
+          <a:fontRef idx="minor">
+            <a:schemeClr val="lt1"/>
+          </a:fontRef>
+        </p:style>
+        <p:txBody>
+          <a:bodyPr rtlCol="0" anchor="ctr"/>
+          <a:lstStyle/>
+          <a:p>
+            <a:pPr algn="ctr"/>
+            <a:endParaRPr lang="zh-CN" altLang="en-US"/>
+          </a:p>
+        </p:txBody>
+      </p:sp>
     </p:spTree>
     <p:extLst>
       <p:ext uri="{BB962C8B-B14F-4D97-AF65-F5344CB8AC3E}">
-        <p14:creationId xmlns:p14="http://schemas.microsoft.com/office/powerpoint/2010/main" val="352971893"/>
+        <p14:creationId xmlns:p14="http://schemas.microsoft.com/office/powerpoint/2010/main" val="3486368323"/>
       </p:ext>
     </p:extLst>
   </p:cSld>

</xml_diff>

<commit_message>
modified the referencesbib and add the month
</commit_message>
<xml_diff>
--- a/plotting/流程图/final.pptx
+++ b/plotting/流程图/final.pptx
@@ -21287,7 +21287,7 @@
                 <a:latin typeface="Times New Roman"/>
                 <a:cs typeface="Times New Roman"/>
               </a:rPr>
-              <a:t> 4</a:t>
+              <a:t> 5</a:t>
             </a:r>
             <a:endParaRPr lang="zh-CN" altLang="en-US" sz="1600" dirty="0">
               <a:solidFill>
@@ -21481,7 +21481,7 @@
                 <a:latin typeface="Times New Roman"/>
                 <a:cs typeface="Times New Roman"/>
               </a:rPr>
-              <a:t> 5</a:t>
+              <a:t> 4</a:t>
             </a:r>
             <a:endParaRPr lang="zh-CN" altLang="en-US" sz="1600" dirty="0">
               <a:solidFill>

</xml_diff>